<commit_message>
docs: clearer 8-metric slide in offsite deck (iteration 42)
</commit_message>
<xml_diff>
--- a/docs/05-summary/offsite-deck.pptx
+++ b/docs/05-summary/offsite-deck.pptx
@@ -118,7 +118,7 @@
   <p:extLst>
     <p:ext uri="{521415D9-36F7-43E2-AB2F-B90AF26B5E84}">
       <p14:sectionLst xmlns:p14="http://schemas.microsoft.com/office/powerpoint/2010/main">
-        <p14:section name="Offsite" id="{c8ab3764-d6c2-1fa9-09cc-7513477dec05}">
+        <p14:section name="Offsite" id="{c6038c55-56fa-8eb0-82fe-d80fe897b60e}">
           <p14:sldIdLst>
             <p14:sldId id="256"/>
             <p14:sldId id="257"/>
@@ -908,7 +908,7 @@
           <a:p>
             <a:r>
               <a:rPr lang="en-US" dirty="0"/>
-              <a:t>Baseline: 2025 vs 2026, MI tickets excluded. D2, D4, D5 per team need ServiceNow read access (request REQ0120210 pending).</a:t>
+              <a:t>Baseline: 2025 vs 2026, MI tickets excluded. Bold green line = value today (2025 to 2026). D2, D4, D5 per team need ServiceNow read access (request REQ0120210 pending).</a:t>
             </a:r>
             <a:endParaRPr lang="en-US" dirty="0"/>
           </a:p>
@@ -2795,12 +2795,12 @@
         </p:nvSpPr>
         <p:spPr>
           <a:xfrm>
-            <a:off x="548640" y="1463040"/>
-            <a:ext cx="2606040" cy="1737360"/>
+            <a:off x="548640" y="1371600"/>
+            <a:ext cx="2606040" cy="2103120"/>
           </a:xfrm>
           <a:prstGeom prst="roundRect">
             <a:avLst>
-              <a:gd name="adj" fmla="val 4211"/>
+              <a:gd name="adj" fmla="val 3478"/>
             </a:avLst>
           </a:prstGeom>
           <a:solidFill>
@@ -2822,8 +2822,8 @@
         </p:nvSpPr>
         <p:spPr>
           <a:xfrm>
-            <a:off x="777240" y="1645920"/>
-            <a:ext cx="2103120" cy="548640"/>
+            <a:off x="731520" y="1508760"/>
+            <a:ext cx="2286000" cy="411480"/>
           </a:xfrm>
           <a:prstGeom prst="rect">
             <a:avLst/>
@@ -2839,7 +2839,7 @@
               <a:buNone/>
             </a:pPr>
             <a:r>
-              <a:rPr lang="en-US" sz="2800" b="1" dirty="0">
+              <a:rPr lang="en-US" sz="1700" b="1" dirty="0">
                 <a:solidFill>
                   <a:schemeClr val="accent1"/>
                 </a:solidFill>
@@ -2847,9 +2847,20 @@
                 <a:ea typeface="Cambria" pitchFamily="34" charset="-122"/>
                 <a:cs typeface="Cambria" pitchFamily="34" charset="-120"/>
               </a:rPr>
-              <a:t>D1</a:t>
-            </a:r>
-            <a:endParaRPr lang="en-US" sz="2800" dirty="0"/>
+              <a:t>D1  </a:t>
+            </a:r>
+            <a:pPr indent="0" marL="0">
+              <a:buNone/>
+            </a:pPr>
+            <a:r>
+              <a:rPr lang="en-US" sz="1700" b="1" dirty="0">
+                <a:solidFill>
+                  <a:schemeClr val="tx1"/>
+                </a:solidFill>
+              </a:rPr>
+              <a:t>Business correctness</a:t>
+            </a:r>
+            <a:endParaRPr lang="en-US" sz="1700" dirty="0"/>
           </a:p>
         </p:txBody>
       </p:sp>
@@ -2861,8 +2872,8 @@
         </p:nvSpPr>
         <p:spPr>
           <a:xfrm>
-            <a:off x="777240" y="2331720"/>
-            <a:ext cx="2194560" cy="731520"/>
+            <a:off x="731520" y="2011680"/>
+            <a:ext cx="2286000" cy="777240"/>
           </a:xfrm>
           <a:prstGeom prst="rect">
             <a:avLst/>
@@ -2878,31 +2889,67 @@
               <a:buNone/>
             </a:pPr>
             <a:r>
-              <a:rPr lang="en-US" sz="1600" b="1" dirty="0">
+              <a:rPr lang="en-US" sz="1400" dirty="0">
                 <a:solidFill>
                   <a:schemeClr val="tx1"/>
                 </a:solidFill>
               </a:rPr>
-              <a:t>Business correctness</a:t>
-            </a:r>
-            <a:endParaRPr lang="en-US" sz="1600" dirty="0"/>
-          </a:p>
-        </p:txBody>
-      </p:sp>
-      <p:sp>
-        <p:nvSpPr>
-          <p:cNvPr id="7" name="dim-1"/>
+              <a:t>Product does the wrong thing: data, routing, lifecycle</a:t>
+            </a:r>
+            <a:endParaRPr lang="en-US" sz="1400" dirty="0"/>
+          </a:p>
+        </p:txBody>
+      </p:sp>
+      <p:sp>
+        <p:nvSpPr>
+          <p:cNvPr id="7" name="Text 4"/>
+          <p:cNvSpPr txBox="1"/>
+          <p:nvPr/>
+        </p:nvSpPr>
+        <p:spPr>
+          <a:xfrm>
+            <a:off x="731520" y="2834640"/>
+            <a:ext cx="2286000" cy="502920"/>
+          </a:xfrm>
+          <a:prstGeom prst="rect">
+            <a:avLst/>
+          </a:prstGeom>
+          <a:noFill/>
+          <a:ln/>
+        </p:spPr>
+        <p:txBody>
+          <a:bodyPr wrap="square" lIns="0" tIns="0" rIns="0" bIns="0" rtlCol="0" anchor="t"/>
+          <a:lstStyle/>
+          <a:p>
+            <a:pPr indent="0" marL="0">
+              <a:buNone/>
+            </a:pPr>
+            <a:r>
+              <a:rPr lang="en-US" sz="1300" b="1" dirty="0">
+                <a:solidFill>
+                  <a:schemeClr val="accent2"/>
+                </a:solidFill>
+              </a:rPr>
+              <a:t>P1/P2 share 52% to 70%</a:t>
+            </a:r>
+            <a:endParaRPr lang="en-US" sz="1300" dirty="0"/>
+          </a:p>
+        </p:txBody>
+      </p:sp>
+      <p:sp>
+        <p:nvSpPr>
+          <p:cNvPr id="8" name="dim-1"/>
           <p:cNvSpPr/>
           <p:nvPr/>
         </p:nvSpPr>
         <p:spPr>
           <a:xfrm>
-            <a:off x="3355848" y="1463040"/>
-            <a:ext cx="2606040" cy="1737360"/>
+            <a:off x="3355848" y="1371600"/>
+            <a:ext cx="2606040" cy="2103120"/>
           </a:xfrm>
           <a:prstGeom prst="roundRect">
             <a:avLst>
-              <a:gd name="adj" fmla="val 4211"/>
+              <a:gd name="adj" fmla="val 3478"/>
             </a:avLst>
           </a:prstGeom>
           <a:solidFill>
@@ -2918,14 +2965,14 @@
       </p:sp>
       <p:sp>
         <p:nvSpPr>
-          <p:cNvPr id="8" name="Text 5"/>
+          <p:cNvPr id="9" name="Text 6"/>
           <p:cNvSpPr txBox="1"/>
           <p:nvPr/>
         </p:nvSpPr>
         <p:spPr>
           <a:xfrm>
-            <a:off x="3584448" y="1645920"/>
-            <a:ext cx="2103120" cy="548640"/>
+            <a:off x="3538728" y="1508760"/>
+            <a:ext cx="2286000" cy="411480"/>
           </a:xfrm>
           <a:prstGeom prst="rect">
             <a:avLst/>
@@ -2941,7 +2988,7 @@
               <a:buNone/>
             </a:pPr>
             <a:r>
-              <a:rPr lang="en-US" sz="2800" b="1" dirty="0">
+              <a:rPr lang="en-US" sz="1700" b="1" dirty="0">
                 <a:solidFill>
                   <a:schemeClr val="accent1"/>
                 </a:solidFill>
@@ -2949,22 +2996,33 @@
                 <a:ea typeface="Cambria" pitchFamily="34" charset="-122"/>
                 <a:cs typeface="Cambria" pitchFamily="34" charset="-120"/>
               </a:rPr>
-              <a:t>D2</a:t>
-            </a:r>
-            <a:endParaRPr lang="en-US" sz="2800" dirty="0"/>
-          </a:p>
-        </p:txBody>
-      </p:sp>
-      <p:sp>
-        <p:nvSpPr>
-          <p:cNvPr id="9" name="Text 6"/>
+              <a:t>D2  </a:t>
+            </a:r>
+            <a:pPr indent="0" marL="0">
+              <a:buNone/>
+            </a:pPr>
+            <a:r>
+              <a:rPr lang="en-US" sz="1700" b="1" dirty="0">
+                <a:solidFill>
+                  <a:schemeClr val="tx1"/>
+                </a:solidFill>
+              </a:rPr>
+              <a:t>Availability</a:t>
+            </a:r>
+            <a:endParaRPr lang="en-US" sz="1700" dirty="0"/>
+          </a:p>
+        </p:txBody>
+      </p:sp>
+      <p:sp>
+        <p:nvSpPr>
+          <p:cNvPr id="10" name="Text 7"/>
           <p:cNvSpPr txBox="1"/>
           <p:nvPr/>
         </p:nvSpPr>
         <p:spPr>
           <a:xfrm>
-            <a:off x="3584448" y="2331720"/>
-            <a:ext cx="2194560" cy="731520"/>
+            <a:off x="3538728" y="2011680"/>
+            <a:ext cx="2286000" cy="777240"/>
           </a:xfrm>
           <a:prstGeom prst="rect">
             <a:avLst/>
@@ -2980,31 +3038,67 @@
               <a:buNone/>
             </a:pPr>
             <a:r>
-              <a:rPr lang="en-US" sz="1600" b="1" dirty="0">
+              <a:rPr lang="en-US" sz="1400" dirty="0">
                 <a:solidFill>
                   <a:schemeClr val="tx1"/>
                 </a:solidFill>
               </a:rPr>
-              <a:t>Availability</a:t>
-            </a:r>
-            <a:endParaRPr lang="en-US" sz="1600" dirty="0"/>
-          </a:p>
-        </p:txBody>
-      </p:sp>
-      <p:sp>
-        <p:nvSpPr>
-          <p:cNvPr id="10" name="dim-2"/>
+              <a:t>P1 incidents per quarter and customers hit</a:t>
+            </a:r>
+            <a:endParaRPr lang="en-US" sz="1400" dirty="0"/>
+          </a:p>
+        </p:txBody>
+      </p:sp>
+      <p:sp>
+        <p:nvSpPr>
+          <p:cNvPr id="11" name="Text 8"/>
+          <p:cNvSpPr txBox="1"/>
+          <p:nvPr/>
+        </p:nvSpPr>
+        <p:spPr>
+          <a:xfrm>
+            <a:off x="3538728" y="2834640"/>
+            <a:ext cx="2286000" cy="502920"/>
+          </a:xfrm>
+          <a:prstGeom prst="rect">
+            <a:avLst/>
+          </a:prstGeom>
+          <a:noFill/>
+          <a:ln/>
+        </p:spPr>
+        <p:txBody>
+          <a:bodyPr wrap="square" lIns="0" tIns="0" rIns="0" bIns="0" rtlCol="0" anchor="t"/>
+          <a:lstStyle/>
+          <a:p>
+            <a:pPr indent="0" marL="0">
+              <a:buNone/>
+            </a:pPr>
+            <a:r>
+              <a:rPr lang="en-US" sz="1300" b="1" dirty="0">
+                <a:solidFill>
+                  <a:schemeClr val="accent2"/>
+                </a:solidFill>
+              </a:rPr>
+              <a:t>About 150 to 76 (cause open)</a:t>
+            </a:r>
+            <a:endParaRPr lang="en-US" sz="1300" dirty="0"/>
+          </a:p>
+        </p:txBody>
+      </p:sp>
+      <p:sp>
+        <p:nvSpPr>
+          <p:cNvPr id="12" name="dim-2"/>
           <p:cNvSpPr/>
           <p:nvPr/>
         </p:nvSpPr>
         <p:spPr>
           <a:xfrm>
-            <a:off x="6163056" y="1463040"/>
-            <a:ext cx="2606040" cy="1737360"/>
+            <a:off x="6163056" y="1371600"/>
+            <a:ext cx="2606040" cy="2103120"/>
           </a:xfrm>
           <a:prstGeom prst="roundRect">
             <a:avLst>
-              <a:gd name="adj" fmla="val 4211"/>
+              <a:gd name="adj" fmla="val 3478"/>
             </a:avLst>
           </a:prstGeom>
           <a:solidFill>
@@ -3020,14 +3114,14 @@
       </p:sp>
       <p:sp>
         <p:nvSpPr>
-          <p:cNvPr id="11" name="Text 8"/>
+          <p:cNvPr id="13" name="Text 10"/>
           <p:cNvSpPr txBox="1"/>
           <p:nvPr/>
         </p:nvSpPr>
         <p:spPr>
           <a:xfrm>
-            <a:off x="6391656" y="1645920"/>
-            <a:ext cx="2103120" cy="548640"/>
+            <a:off x="6345936" y="1508760"/>
+            <a:ext cx="2286000" cy="411480"/>
           </a:xfrm>
           <a:prstGeom prst="rect">
             <a:avLst/>
@@ -3043,7 +3137,7 @@
               <a:buNone/>
             </a:pPr>
             <a:r>
-              <a:rPr lang="en-US" sz="2800" b="1" dirty="0">
+              <a:rPr lang="en-US" sz="1700" b="1" dirty="0">
                 <a:solidFill>
                   <a:schemeClr val="accent1"/>
                 </a:solidFill>
@@ -3051,22 +3145,33 @@
                 <a:ea typeface="Cambria" pitchFamily="34" charset="-122"/>
                 <a:cs typeface="Cambria" pitchFamily="34" charset="-120"/>
               </a:rPr>
-              <a:t>D3</a:t>
-            </a:r>
-            <a:endParaRPr lang="en-US" sz="2800" dirty="0"/>
-          </a:p>
-        </p:txBody>
-      </p:sp>
-      <p:sp>
-        <p:nvSpPr>
-          <p:cNvPr id="12" name="Text 9"/>
+              <a:t>D3  </a:t>
+            </a:r>
+            <a:pPr indent="0" marL="0">
+              <a:buNone/>
+            </a:pPr>
+            <a:r>
+              <a:rPr lang="en-US" sz="1700" b="1" dirty="0">
+                <a:solidFill>
+                  <a:schemeClr val="tx1"/>
+                </a:solidFill>
+              </a:rPr>
+              <a:t>Performance</a:t>
+            </a:r>
+            <a:endParaRPr lang="en-US" sz="1700" dirty="0"/>
+          </a:p>
+        </p:txBody>
+      </p:sp>
+      <p:sp>
+        <p:nvSpPr>
+          <p:cNvPr id="14" name="Text 11"/>
           <p:cNvSpPr txBox="1"/>
           <p:nvPr/>
         </p:nvSpPr>
         <p:spPr>
           <a:xfrm>
-            <a:off x="6391656" y="2331720"/>
-            <a:ext cx="2194560" cy="731520"/>
+            <a:off x="6345936" y="2011680"/>
+            <a:ext cx="2286000" cy="777240"/>
           </a:xfrm>
           <a:prstGeom prst="rect">
             <a:avLst/>
@@ -3082,31 +3187,67 @@
               <a:buNone/>
             </a:pPr>
             <a:r>
-              <a:rPr lang="en-US" sz="1600" b="1" dirty="0">
+              <a:rPr lang="en-US" sz="1400" dirty="0">
                 <a:solidFill>
                   <a:schemeClr val="tx1"/>
                 </a:solidFill>
               </a:rPr>
-              <a:t>Performance</a:t>
-            </a:r>
-            <a:endParaRPr lang="en-US" sz="1600" dirty="0"/>
-          </a:p>
-        </p:txBody>
-      </p:sp>
-      <p:sp>
-        <p:nvSpPr>
-          <p:cNvPr id="13" name="dim-3"/>
+              <a:t>Slow-system bugs and SLO breaches</a:t>
+            </a:r>
+            <a:endParaRPr lang="en-US" sz="1400" dirty="0"/>
+          </a:p>
+        </p:txBody>
+      </p:sp>
+      <p:sp>
+        <p:nvSpPr>
+          <p:cNvPr id="15" name="Text 12"/>
+          <p:cNvSpPr txBox="1"/>
+          <p:nvPr/>
+        </p:nvSpPr>
+        <p:spPr>
+          <a:xfrm>
+            <a:off x="6345936" y="2834640"/>
+            <a:ext cx="2286000" cy="502920"/>
+          </a:xfrm>
+          <a:prstGeom prst="rect">
+            <a:avLst/>
+          </a:prstGeom>
+          <a:noFill/>
+          <a:ln/>
+        </p:spPr>
+        <p:txBody>
+          <a:bodyPr wrap="square" lIns="0" tIns="0" rIns="0" bIns="0" rtlCol="0" anchor="t"/>
+          <a:lstStyle/>
+          <a:p>
+            <a:pPr indent="0" marL="0">
+              <a:buNone/>
+            </a:pPr>
+            <a:r>
+              <a:rPr lang="en-US" sz="1300" b="1" dirty="0">
+                <a:solidFill>
+                  <a:schemeClr val="accent2"/>
+                </a:solidFill>
+              </a:rPr>
+              <a:t>No SLO data yet</a:t>
+            </a:r>
+            <a:endParaRPr lang="en-US" sz="1300" dirty="0"/>
+          </a:p>
+        </p:txBody>
+      </p:sp>
+      <p:sp>
+        <p:nvSpPr>
+          <p:cNvPr id="16" name="dim-3"/>
           <p:cNvSpPr/>
           <p:nvPr/>
         </p:nvSpPr>
         <p:spPr>
           <a:xfrm>
-            <a:off x="8970264" y="1463040"/>
-            <a:ext cx="2606040" cy="1737360"/>
+            <a:off x="8970264" y="1371600"/>
+            <a:ext cx="2606040" cy="2103120"/>
           </a:xfrm>
           <a:prstGeom prst="roundRect">
             <a:avLst>
-              <a:gd name="adj" fmla="val 4211"/>
+              <a:gd name="adj" fmla="val 3478"/>
             </a:avLst>
           </a:prstGeom>
           <a:solidFill>
@@ -3122,14 +3263,14 @@
       </p:sp>
       <p:sp>
         <p:nvSpPr>
-          <p:cNvPr id="14" name="Text 11"/>
+          <p:cNvPr id="17" name="Text 14"/>
           <p:cNvSpPr txBox="1"/>
           <p:nvPr/>
         </p:nvSpPr>
         <p:spPr>
           <a:xfrm>
-            <a:off x="9198864" y="1645920"/>
-            <a:ext cx="2103120" cy="548640"/>
+            <a:off x="9153144" y="1508760"/>
+            <a:ext cx="2286000" cy="411480"/>
           </a:xfrm>
           <a:prstGeom prst="rect">
             <a:avLst/>
@@ -3145,7 +3286,7 @@
               <a:buNone/>
             </a:pPr>
             <a:r>
-              <a:rPr lang="en-US" sz="2800" b="1" dirty="0">
+              <a:rPr lang="en-US" sz="1700" b="1" dirty="0">
                 <a:solidFill>
                   <a:schemeClr val="accent1"/>
                 </a:solidFill>
@@ -3153,22 +3294,33 @@
                 <a:ea typeface="Cambria" pitchFamily="34" charset="-122"/>
                 <a:cs typeface="Cambria" pitchFamily="34" charset="-120"/>
               </a:rPr>
-              <a:t>D4</a:t>
-            </a:r>
-            <a:endParaRPr lang="en-US" sz="2800" dirty="0"/>
-          </a:p>
-        </p:txBody>
-      </p:sp>
-      <p:sp>
-        <p:nvSpPr>
-          <p:cNvPr id="15" name="Text 12"/>
+              <a:t>D4  </a:t>
+            </a:r>
+            <a:pPr indent="0" marL="0">
+              <a:buNone/>
+            </a:pPr>
+            <a:r>
+              <a:rPr lang="en-US" sz="1700" b="1" dirty="0">
+                <a:solidFill>
+                  <a:schemeClr val="tx1"/>
+                </a:solidFill>
+              </a:rPr>
+              <a:t>Detection</a:t>
+            </a:r>
+            <a:endParaRPr lang="en-US" sz="1700" dirty="0"/>
+          </a:p>
+        </p:txBody>
+      </p:sp>
+      <p:sp>
+        <p:nvSpPr>
+          <p:cNvPr id="18" name="Text 15"/>
           <p:cNvSpPr txBox="1"/>
           <p:nvPr/>
         </p:nvSpPr>
         <p:spPr>
           <a:xfrm>
-            <a:off x="9198864" y="2331720"/>
-            <a:ext cx="2194560" cy="731520"/>
+            <a:off x="9153144" y="2011680"/>
+            <a:ext cx="2286000" cy="777240"/>
           </a:xfrm>
           <a:prstGeom prst="rect">
             <a:avLst/>
@@ -3184,31 +3336,67 @@
               <a:buNone/>
             </a:pPr>
             <a:r>
-              <a:rPr lang="en-US" sz="1600" b="1" dirty="0">
+              <a:rPr lang="en-US" sz="1400" dirty="0">
                 <a:solidFill>
                   <a:schemeClr val="tx1"/>
                 </a:solidFill>
               </a:rPr>
-              <a:t>Detection: found by us first</a:t>
-            </a:r>
-            <a:endParaRPr lang="en-US" sz="1600" dirty="0"/>
-          </a:p>
-        </p:txBody>
-      </p:sp>
-      <p:sp>
-        <p:nvSpPr>
-          <p:cNvPr id="16" name="dim-4"/>
+              <a:t>Share of impact we find before customers</a:t>
+            </a:r>
+            <a:endParaRPr lang="en-US" sz="1400" dirty="0"/>
+          </a:p>
+        </p:txBody>
+      </p:sp>
+      <p:sp>
+        <p:nvSpPr>
+          <p:cNvPr id="19" name="Text 16"/>
+          <p:cNvSpPr txBox="1"/>
+          <p:nvPr/>
+        </p:nvSpPr>
+        <p:spPr>
+          <a:xfrm>
+            <a:off x="9153144" y="2834640"/>
+            <a:ext cx="2286000" cy="502920"/>
+          </a:xfrm>
+          <a:prstGeom prst="rect">
+            <a:avLst/>
+          </a:prstGeom>
+          <a:noFill/>
+          <a:ln/>
+        </p:spPr>
+        <p:txBody>
+          <a:bodyPr wrap="square" lIns="0" tIns="0" rIns="0" bIns="0" rtlCol="0" anchor="t"/>
+          <a:lstStyle/>
+          <a:p>
+            <a:pPr indent="0" marL="0">
+              <a:buNone/>
+            </a:pPr>
+            <a:r>
+              <a:rPr lang="en-US" sz="1300" b="1" dirty="0">
+                <a:solidFill>
+                  <a:schemeClr val="accent2"/>
+                </a:solidFill>
+              </a:rPr>
+              <a:t>96% of P1 via customers</a:t>
+            </a:r>
+            <a:endParaRPr lang="en-US" sz="1300" dirty="0"/>
+          </a:p>
+        </p:txBody>
+      </p:sp>
+      <p:sp>
+        <p:nvSpPr>
+          <p:cNvPr id="20" name="dim-4"/>
           <p:cNvSpPr/>
           <p:nvPr/>
         </p:nvSpPr>
         <p:spPr>
           <a:xfrm>
-            <a:off x="548640" y="3474720"/>
-            <a:ext cx="2606040" cy="1737360"/>
+            <a:off x="548640" y="3611880"/>
+            <a:ext cx="2606040" cy="2103120"/>
           </a:xfrm>
           <a:prstGeom prst="roundRect">
             <a:avLst>
-              <a:gd name="adj" fmla="val 4211"/>
+              <a:gd name="adj" fmla="val 3478"/>
             </a:avLst>
           </a:prstGeom>
           <a:solidFill>
@@ -3224,14 +3412,14 @@
       </p:sp>
       <p:sp>
         <p:nvSpPr>
-          <p:cNvPr id="17" name="Text 14"/>
+          <p:cNvPr id="21" name="Text 18"/>
           <p:cNvSpPr txBox="1"/>
           <p:nvPr/>
         </p:nvSpPr>
         <p:spPr>
           <a:xfrm>
-            <a:off x="777240" y="3657600"/>
-            <a:ext cx="2103120" cy="548640"/>
+            <a:off x="731520" y="3749040"/>
+            <a:ext cx="2286000" cy="411480"/>
           </a:xfrm>
           <a:prstGeom prst="rect">
             <a:avLst/>
@@ -3247,7 +3435,7 @@
               <a:buNone/>
             </a:pPr>
             <a:r>
-              <a:rPr lang="en-US" sz="2800" b="1" dirty="0">
+              <a:rPr lang="en-US" sz="1700" b="1" dirty="0">
                 <a:solidFill>
                   <a:schemeClr val="accent1"/>
                 </a:solidFill>
@@ -3255,22 +3443,33 @@
                 <a:ea typeface="Cambria" pitchFamily="34" charset="-122"/>
                 <a:cs typeface="Cambria" pitchFamily="34" charset="-120"/>
               </a:rPr>
-              <a:t>D5</a:t>
-            </a:r>
-            <a:endParaRPr lang="en-US" sz="2800" dirty="0"/>
-          </a:p>
-        </p:txBody>
-      </p:sp>
-      <p:sp>
-        <p:nvSpPr>
-          <p:cNvPr id="18" name="Text 15"/>
+              <a:t>D5  </a:t>
+            </a:r>
+            <a:pPr indent="0" marL="0">
+              <a:buNone/>
+            </a:pPr>
+            <a:r>
+              <a:rPr lang="en-US" sz="1700" b="1" dirty="0">
+                <a:solidFill>
+                  <a:schemeClr val="tx1"/>
+                </a:solidFill>
+              </a:rPr>
+              <a:t>Recovery</a:t>
+            </a:r>
+            <a:endParaRPr lang="en-US" sz="1700" dirty="0"/>
+          </a:p>
+        </p:txBody>
+      </p:sp>
+      <p:sp>
+        <p:nvSpPr>
+          <p:cNvPr id="22" name="Text 19"/>
           <p:cNvSpPr txBox="1"/>
           <p:nvPr/>
         </p:nvSpPr>
         <p:spPr>
           <a:xfrm>
-            <a:off x="777240" y="4343400"/>
-            <a:ext cx="2194560" cy="731520"/>
+            <a:off x="731520" y="4251960"/>
+            <a:ext cx="2286000" cy="777240"/>
           </a:xfrm>
           <a:prstGeom prst="rect">
             <a:avLst/>
@@ -3286,31 +3485,67 @@
               <a:buNone/>
             </a:pPr>
             <a:r>
-              <a:rPr lang="en-US" sz="1600" b="1" dirty="0">
+              <a:rPr lang="en-US" sz="1400" dirty="0">
                 <a:solidFill>
                   <a:schemeClr val="tx1"/>
                 </a:solidFill>
               </a:rPr>
-              <a:t>Recovery time</a:t>
-            </a:r>
-            <a:endParaRPr lang="en-US" sz="1600" dirty="0"/>
-          </a:p>
-        </p:txBody>
-      </p:sp>
-      <p:sp>
-        <p:nvSpPr>
-          <p:cNvPr id="19" name="dim-5"/>
+              <a:t>Time to restore and time to fix a bug</a:t>
+            </a:r>
+            <a:endParaRPr lang="en-US" sz="1400" dirty="0"/>
+          </a:p>
+        </p:txBody>
+      </p:sp>
+      <p:sp>
+        <p:nvSpPr>
+          <p:cNvPr id="23" name="Text 20"/>
+          <p:cNvSpPr txBox="1"/>
+          <p:nvPr/>
+        </p:nvSpPr>
+        <p:spPr>
+          <a:xfrm>
+            <a:off x="731520" y="5074920"/>
+            <a:ext cx="2286000" cy="502920"/>
+          </a:xfrm>
+          <a:prstGeom prst="rect">
+            <a:avLst/>
+          </a:prstGeom>
+          <a:noFill/>
+          <a:ln/>
+        </p:spPr>
+        <p:txBody>
+          <a:bodyPr wrap="square" lIns="0" tIns="0" rIns="0" bIns="0" rtlCol="0" anchor="t"/>
+          <a:lstStyle/>
+          <a:p>
+            <a:pPr indent="0" marL="0">
+              <a:buNone/>
+            </a:pPr>
+            <a:r>
+              <a:rPr lang="en-US" sz="1300" b="1" dirty="0">
+                <a:solidFill>
+                  <a:schemeClr val="accent2"/>
+                </a:solidFill>
+              </a:rPr>
+              <a:t>Fix median 10 days</a:t>
+            </a:r>
+            <a:endParaRPr lang="en-US" sz="1300" dirty="0"/>
+          </a:p>
+        </p:txBody>
+      </p:sp>
+      <p:sp>
+        <p:nvSpPr>
+          <p:cNvPr id="24" name="dim-5"/>
           <p:cNvSpPr/>
           <p:nvPr/>
         </p:nvSpPr>
         <p:spPr>
           <a:xfrm>
-            <a:off x="3355848" y="3474720"/>
-            <a:ext cx="2606040" cy="1737360"/>
+            <a:off x="3355848" y="3611880"/>
+            <a:ext cx="2606040" cy="2103120"/>
           </a:xfrm>
           <a:prstGeom prst="roundRect">
             <a:avLst>
-              <a:gd name="adj" fmla="val 4211"/>
+              <a:gd name="adj" fmla="val 3478"/>
             </a:avLst>
           </a:prstGeom>
           <a:solidFill>
@@ -3326,14 +3561,14 @@
       </p:sp>
       <p:sp>
         <p:nvSpPr>
-          <p:cNvPr id="20" name="Text 17"/>
+          <p:cNvPr id="25" name="Text 22"/>
           <p:cNvSpPr txBox="1"/>
           <p:nvPr/>
         </p:nvSpPr>
         <p:spPr>
           <a:xfrm>
-            <a:off x="3584448" y="3657600"/>
-            <a:ext cx="2103120" cy="548640"/>
+            <a:off x="3538728" y="3749040"/>
+            <a:ext cx="2286000" cy="411480"/>
           </a:xfrm>
           <a:prstGeom prst="rect">
             <a:avLst/>
@@ -3349,7 +3584,7 @@
               <a:buNone/>
             </a:pPr>
             <a:r>
-              <a:rPr lang="en-US" sz="2800" b="1" dirty="0">
+              <a:rPr lang="en-US" sz="1700" b="1" dirty="0">
                 <a:solidFill>
                   <a:schemeClr val="accent1"/>
                 </a:solidFill>
@@ -3357,22 +3592,33 @@
                 <a:ea typeface="Cambria" pitchFamily="34" charset="-122"/>
                 <a:cs typeface="Cambria" pitchFamily="34" charset="-120"/>
               </a:rPr>
-              <a:t>D6</a:t>
-            </a:r>
-            <a:endParaRPr lang="en-US" sz="2800" dirty="0"/>
-          </a:p>
-        </p:txBody>
-      </p:sp>
-      <p:sp>
-        <p:nvSpPr>
-          <p:cNvPr id="21" name="Text 18"/>
+              <a:t>D6  </a:t>
+            </a:r>
+            <a:pPr indent="0" marL="0">
+              <a:buNone/>
+            </a:pPr>
+            <a:r>
+              <a:rPr lang="en-US" sz="1700" b="1" dirty="0">
+                <a:solidFill>
+                  <a:schemeClr val="tx1"/>
+                </a:solidFill>
+              </a:rPr>
+              <a:t>Change safety</a:t>
+            </a:r>
+            <a:endParaRPr lang="en-US" sz="1700" dirty="0"/>
+          </a:p>
+        </p:txBody>
+      </p:sp>
+      <p:sp>
+        <p:nvSpPr>
+          <p:cNvPr id="26" name="Text 23"/>
           <p:cNvSpPr txBox="1"/>
           <p:nvPr/>
         </p:nvSpPr>
         <p:spPr>
           <a:xfrm>
-            <a:off x="3584448" y="4343400"/>
-            <a:ext cx="2194560" cy="731520"/>
+            <a:off x="3538728" y="4251960"/>
+            <a:ext cx="2286000" cy="777240"/>
           </a:xfrm>
           <a:prstGeom prst="rect">
             <a:avLst/>
@@ -3388,31 +3634,67 @@
               <a:buNone/>
             </a:pPr>
             <a:r>
-              <a:rPr lang="en-US" sz="1600" b="1" dirty="0">
+              <a:rPr lang="en-US" sz="1400" dirty="0">
                 <a:solidFill>
                   <a:schemeClr val="tx1"/>
                 </a:solidFill>
               </a:rPr>
-              <a:t>Change safety</a:t>
-            </a:r>
-            <a:endParaRPr lang="en-US" sz="1600" dirty="0"/>
-          </a:p>
-        </p:txBody>
-      </p:sp>
-      <p:sp>
-        <p:nvSpPr>
-          <p:cNvPr id="22" name="dim-6"/>
+              <a:t>Bugs caused by fixes, emergency or recent changes</a:t>
+            </a:r>
+            <a:endParaRPr lang="en-US" sz="1400" dirty="0"/>
+          </a:p>
+        </p:txBody>
+      </p:sp>
+      <p:sp>
+        <p:nvSpPr>
+          <p:cNvPr id="27" name="Text 24"/>
+          <p:cNvSpPr txBox="1"/>
+          <p:nvPr/>
+        </p:nvSpPr>
+        <p:spPr>
+          <a:xfrm>
+            <a:off x="3538728" y="5074920"/>
+            <a:ext cx="2286000" cy="502920"/>
+          </a:xfrm>
+          <a:prstGeom prst="rect">
+            <a:avLst/>
+          </a:prstGeom>
+          <a:noFill/>
+          <a:ln/>
+        </p:spPr>
+        <p:txBody>
+          <a:bodyPr wrap="square" lIns="0" tIns="0" rIns="0" bIns="0" rtlCol="0" anchor="t"/>
+          <a:lstStyle/>
+          <a:p>
+            <a:pPr indent="0" marL="0">
+              <a:buNone/>
+            </a:pPr>
+            <a:r>
+              <a:rPr lang="en-US" sz="1300" b="1" dirty="0">
+                <a:solidFill>
+                  <a:schemeClr val="accent2"/>
+                </a:solidFill>
+              </a:rPr>
+              <a:t>Fix-caused 24% to 27%</a:t>
+            </a:r>
+            <a:endParaRPr lang="en-US" sz="1300" dirty="0"/>
+          </a:p>
+        </p:txBody>
+      </p:sp>
+      <p:sp>
+        <p:nvSpPr>
+          <p:cNvPr id="28" name="dim-6"/>
           <p:cNvSpPr/>
           <p:nvPr/>
         </p:nvSpPr>
         <p:spPr>
           <a:xfrm>
-            <a:off x="6163056" y="3474720"/>
-            <a:ext cx="2606040" cy="1737360"/>
+            <a:off x="6163056" y="3611880"/>
+            <a:ext cx="2606040" cy="2103120"/>
           </a:xfrm>
           <a:prstGeom prst="roundRect">
             <a:avLst>
-              <a:gd name="adj" fmla="val 4211"/>
+              <a:gd name="adj" fmla="val 3478"/>
             </a:avLst>
           </a:prstGeom>
           <a:solidFill>
@@ -3428,14 +3710,14 @@
       </p:sp>
       <p:sp>
         <p:nvSpPr>
-          <p:cNvPr id="23" name="Text 20"/>
+          <p:cNvPr id="29" name="Text 26"/>
           <p:cNvSpPr txBox="1"/>
           <p:nvPr/>
         </p:nvSpPr>
         <p:spPr>
           <a:xfrm>
-            <a:off x="6391656" y="3657600"/>
-            <a:ext cx="2103120" cy="548640"/>
+            <a:off x="6345936" y="3749040"/>
+            <a:ext cx="2286000" cy="411480"/>
           </a:xfrm>
           <a:prstGeom prst="rect">
             <a:avLst/>
@@ -3451,7 +3733,7 @@
               <a:buNone/>
             </a:pPr>
             <a:r>
-              <a:rPr lang="en-US" sz="2800" b="1" dirty="0">
+              <a:rPr lang="en-US" sz="1700" b="1" dirty="0">
                 <a:solidFill>
                   <a:schemeClr val="accent1"/>
                 </a:solidFill>
@@ -3459,22 +3741,33 @@
                 <a:ea typeface="Cambria" pitchFamily="34" charset="-122"/>
                 <a:cs typeface="Cambria" pitchFamily="34" charset="-120"/>
               </a:rPr>
-              <a:t>D7</a:t>
-            </a:r>
-            <a:endParaRPr lang="en-US" sz="2800" dirty="0"/>
-          </a:p>
-        </p:txBody>
-      </p:sp>
-      <p:sp>
-        <p:nvSpPr>
-          <p:cNvPr id="24" name="Text 21"/>
+              <a:t>D7  </a:t>
+            </a:r>
+            <a:pPr indent="0" marL="0">
+              <a:buNone/>
+            </a:pPr>
+            <a:r>
+              <a:rPr lang="en-US" sz="1700" b="1" dirty="0">
+                <a:solidFill>
+                  <a:schemeClr val="tx1"/>
+                </a:solidFill>
+              </a:rPr>
+              <a:t>Non-recurrence</a:t>
+            </a:r>
+            <a:endParaRPr lang="en-US" sz="1700" dirty="0"/>
+          </a:p>
+        </p:txBody>
+      </p:sp>
+      <p:sp>
+        <p:nvSpPr>
+          <p:cNvPr id="30" name="Text 27"/>
           <p:cNvSpPr txBox="1"/>
           <p:nvPr/>
         </p:nvSpPr>
         <p:spPr>
           <a:xfrm>
-            <a:off x="6391656" y="4343400"/>
-            <a:ext cx="2194560" cy="731520"/>
+            <a:off x="6345936" y="4251960"/>
+            <a:ext cx="2286000" cy="777240"/>
           </a:xfrm>
           <a:prstGeom prst="rect">
             <a:avLst/>
@@ -3490,31 +3783,67 @@
               <a:buNone/>
             </a:pPr>
             <a:r>
-              <a:rPr lang="en-US" sz="1600" b="1" dirty="0">
+              <a:rPr lang="en-US" sz="1400" dirty="0">
                 <a:solidFill>
                   <a:schemeClr val="tx1"/>
                 </a:solidFill>
               </a:rPr>
-              <a:t>Non-recurrence</a:t>
-            </a:r>
-            <a:endParaRPr lang="en-US" sz="1600" dirty="0"/>
-          </a:p>
-        </p:txBody>
-      </p:sp>
-      <p:sp>
-        <p:nvSpPr>
-          <p:cNvPr id="25" name="dim-7"/>
+              <a:t>Do fixes hold: repeats and reopens</a:t>
+            </a:r>
+            <a:endParaRPr lang="en-US" sz="1400" dirty="0"/>
+          </a:p>
+        </p:txBody>
+      </p:sp>
+      <p:sp>
+        <p:nvSpPr>
+          <p:cNvPr id="31" name="Text 28"/>
+          <p:cNvSpPr txBox="1"/>
+          <p:nvPr/>
+        </p:nvSpPr>
+        <p:spPr>
+          <a:xfrm>
+            <a:off x="6345936" y="5074920"/>
+            <a:ext cx="2286000" cy="502920"/>
+          </a:xfrm>
+          <a:prstGeom prst="rect">
+            <a:avLst/>
+          </a:prstGeom>
+          <a:noFill/>
+          <a:ln/>
+        </p:spPr>
+        <p:txBody>
+          <a:bodyPr wrap="square" lIns="0" tIns="0" rIns="0" bIns="0" rtlCol="0" anchor="t"/>
+          <a:lstStyle/>
+          <a:p>
+            <a:pPr indent="0" marL="0">
+              <a:buNone/>
+            </a:pPr>
+            <a:r>
+              <a:rPr lang="en-US" sz="1300" b="1" dirty="0">
+                <a:solidFill>
+                  <a:schemeClr val="accent2"/>
+                </a:solidFill>
+              </a:rPr>
+              <a:t>Recurrence 3.9% to 1.5%</a:t>
+            </a:r>
+            <a:endParaRPr lang="en-US" sz="1300" dirty="0"/>
+          </a:p>
+        </p:txBody>
+      </p:sp>
+      <p:sp>
+        <p:nvSpPr>
+          <p:cNvPr id="32" name="dim-7"/>
           <p:cNvSpPr/>
           <p:nvPr/>
         </p:nvSpPr>
         <p:spPr>
           <a:xfrm>
-            <a:off x="8970264" y="3474720"/>
-            <a:ext cx="2606040" cy="1737360"/>
+            <a:off x="8970264" y="3611880"/>
+            <a:ext cx="2606040" cy="2103120"/>
           </a:xfrm>
           <a:prstGeom prst="roundRect">
             <a:avLst>
-              <a:gd name="adj" fmla="val 4211"/>
+              <a:gd name="adj" fmla="val 3478"/>
             </a:avLst>
           </a:prstGeom>
           <a:solidFill>
@@ -3530,14 +3859,14 @@
       </p:sp>
       <p:sp>
         <p:nvSpPr>
-          <p:cNvPr id="26" name="Text 23"/>
+          <p:cNvPr id="33" name="Text 30"/>
           <p:cNvSpPr txBox="1"/>
           <p:nvPr/>
         </p:nvSpPr>
         <p:spPr>
           <a:xfrm>
-            <a:off x="9198864" y="3657600"/>
-            <a:ext cx="2103120" cy="548640"/>
+            <a:off x="9153144" y="3749040"/>
+            <a:ext cx="2286000" cy="411480"/>
           </a:xfrm>
           <a:prstGeom prst="rect">
             <a:avLst/>
@@ -3553,7 +3882,7 @@
               <a:buNone/>
             </a:pPr>
             <a:r>
-              <a:rPr lang="en-US" sz="2800" b="1" dirty="0">
+              <a:rPr lang="en-US" sz="1700" b="1" dirty="0">
                 <a:solidFill>
                   <a:schemeClr val="accent1"/>
                 </a:solidFill>
@@ -3561,22 +3890,33 @@
                 <a:ea typeface="Cambria" pitchFamily="34" charset="-122"/>
                 <a:cs typeface="Cambria" pitchFamily="34" charset="-120"/>
               </a:rPr>
-              <a:t>D8</a:t>
-            </a:r>
-            <a:endParaRPr lang="en-US" sz="2800" dirty="0"/>
-          </a:p>
-        </p:txBody>
-      </p:sp>
-      <p:sp>
-        <p:nvSpPr>
-          <p:cNvPr id="27" name="Text 24"/>
+              <a:t>D8  </a:t>
+            </a:r>
+            <a:pPr indent="0" marL="0">
+              <a:buNone/>
+            </a:pPr>
+            <a:r>
+              <a:rPr lang="en-US" sz="1700" b="1" dirty="0">
+                <a:solidFill>
+                  <a:schemeClr val="tx1"/>
+                </a:solidFill>
+              </a:rPr>
+              <a:t>Expectation fit</a:t>
+            </a:r>
+            <a:endParaRPr lang="en-US" sz="1700" dirty="0"/>
+          </a:p>
+        </p:txBody>
+      </p:sp>
+      <p:sp>
+        <p:nvSpPr>
+          <p:cNvPr id="34" name="Text 31"/>
           <p:cNvSpPr txBox="1"/>
           <p:nvPr/>
         </p:nvSpPr>
         <p:spPr>
           <a:xfrm>
-            <a:off x="9198864" y="4343400"/>
-            <a:ext cx="2194560" cy="731520"/>
+            <a:off x="9153144" y="4251960"/>
+            <a:ext cx="2286000" cy="777240"/>
           </a:xfrm>
           <a:prstGeom prst="rect">
             <a:avLst/>
@@ -3592,27 +3932,27 @@
               <a:buNone/>
             </a:pPr>
             <a:r>
-              <a:rPr lang="en-US" sz="1600" b="1" dirty="0">
+              <a:rPr lang="en-US" sz="1400" dirty="0">
                 <a:solidFill>
                   <a:schemeClr val="tx1"/>
                 </a:solidFill>
               </a:rPr>
-              <a:t>Expectation fit</a:t>
-            </a:r>
-            <a:endParaRPr lang="en-US" sz="1600" dirty="0"/>
-          </a:p>
-        </p:txBody>
-      </p:sp>
-      <p:sp>
-        <p:nvSpPr>
-          <p:cNvPr id="28" name="Text 25"/>
+              <a:t>Reports closed as designed that are real gaps</a:t>
+            </a:r>
+            <a:endParaRPr lang="en-US" sz="1400" dirty="0"/>
+          </a:p>
+        </p:txBody>
+      </p:sp>
+      <p:sp>
+        <p:nvSpPr>
+          <p:cNvPr id="35" name="Text 32"/>
           <p:cNvSpPr txBox="1"/>
           <p:nvPr/>
         </p:nvSpPr>
         <p:spPr>
           <a:xfrm>
-            <a:off x="548640" y="5577840"/>
-            <a:ext cx="11064240" cy="457200"/>
+            <a:off x="9153144" y="5074920"/>
+            <a:ext cx="2286000" cy="502920"/>
           </a:xfrm>
           <a:prstGeom prst="rect">
             <a:avLst/>
@@ -3628,14 +3968,50 @@
               <a:buNone/>
             </a:pPr>
             <a:r>
-              <a:rPr lang="en-US" sz="1600" dirty="0">
+              <a:rPr lang="en-US" sz="1300" b="1" dirty="0">
+                <a:solidFill>
+                  <a:schemeClr val="accent2"/>
+                </a:solidFill>
+              </a:rPr>
+              <a:t>42% of those are real gaps</a:t>
+            </a:r>
+            <a:endParaRPr lang="en-US" sz="1300" dirty="0"/>
+          </a:p>
+        </p:txBody>
+      </p:sp>
+      <p:sp>
+        <p:nvSpPr>
+          <p:cNvPr id="36" name="Text 33"/>
+          <p:cNvSpPr txBox="1"/>
+          <p:nvPr/>
+        </p:nvSpPr>
+        <p:spPr>
+          <a:xfrm>
+            <a:off x="548640" y="5943600"/>
+            <a:ext cx="11064240" cy="365760"/>
+          </a:xfrm>
+          <a:prstGeom prst="rect">
+            <a:avLst/>
+          </a:prstGeom>
+          <a:noFill/>
+          <a:ln/>
+        </p:spPr>
+        <p:txBody>
+          <a:bodyPr wrap="square" lIns="0" tIns="0" rIns="0" bIns="0" rtlCol="0" anchor="t"/>
+          <a:lstStyle/>
+          <a:p>
+            <a:pPr indent="0" marL="0">
+              <a:buNone/>
+            </a:pPr>
+            <a:r>
+              <a:rPr lang="en-US" sz="1400" dirty="0">
                 <a:solidFill>
                   <a:schemeClr val="tx2"/>
                 </a:solidFill>
               </a:rPr>
               <a:t>Rule: a pod outside its own range for 2 months gets an investigation, not a punishment.</a:t>
             </a:r>
-            <a:endParaRPr lang="en-US" sz="1600" dirty="0"/>
+            <a:endParaRPr lang="en-US" sz="1400" dirty="0"/>
           </a:p>
         </p:txBody>
       </p:sp>

</xml_diff>

<commit_message>
docs: offsite deck review fixes (iteration 44)
</commit_message>
<xml_diff>
--- a/docs/05-summary/offsite-deck.pptx
+++ b/docs/05-summary/offsite-deck.pptx
@@ -119,7 +119,7 @@
   <p:extLst>
     <p:ext uri="{521415D9-36F7-43E2-AB2F-B90AF26B5E84}">
       <p14:sectionLst xmlns:p14="http://schemas.microsoft.com/office/powerpoint/2010/main">
-        <p14:section name="Offsite" id="{ab3695ca-2d81-9aa6-81e2-d614f8c1c4ad}">
+        <p14:section name="Offsite" id="{04d68d3a-e502-9024-8840-3581a16358b5}">
           <p14:sldIdLst>
             <p14:sldId id="256"/>
             <p14:sldId id="257"/>
@@ -8436,7 +8436,7 @@
                   <a:schemeClr val="tx1"/>
                 </a:solidFill>
               </a:rPr>
-              <a:t>Risk sits in large changes in hotspot code, not in AI</a:t>
+              <a:t>Risk follows change size in hotspot code, not AI use</a:t>
             </a:r>
             <a:endParaRPr lang="en-US" sz="3000" dirty="0"/>
           </a:p>
@@ -9729,7 +9729,7 @@
         </p:nvSpPr>
         <p:spPr>
           <a:xfrm>
-            <a:off x="548640" y="5669280"/>
+            <a:off x="548640" y="5852160"/>
             <a:ext cx="11064240" cy="457200"/>
           </a:xfrm>
           <a:prstGeom prst="rect">

</xml_diff>